<commit_message>
feat(site): retire windrose and rebalance evidence layouts
Co-authored-by: arena-agent <297053741+arena-agent@users.noreply.github.com>
</commit_message>
<xml_diff>
--- a/8.23组会汇报_可视化暑期进展_孙承泽.pptx
+++ b/8.23组会汇报_可视化暑期进展_孙承泽.pptx
@@ -4029,7 +4029,7 @@
               </a:defRPr>
             </a:pPr>
             <a:r>
-              <a:t>16页莫兰迪静态工作台</a:t>
+              <a:t>15页莫兰迪静态工作台</a:t>
             </a:r>
             <a:br/>
             <a:r>
@@ -5250,7 +5250,7 @@
             </a:r>
             <a:br/>
             <a:r>
-              <a:t>   统筹全系 16 个莫兰迪工科子网页研发，首创纯静态插值推理与全时段协同呈现！</a:t>
+              <a:t>   统筹全系 15 个莫兰迪工科页面研发，首创纯静态插值推理与全时段协同呈现！</a:t>
             </a:r>
           </a:p>
         </p:txBody>

</xml_diff>